<commit_message>
Fix comment on dvc stage add command
</commit_message>
<xml_diff>
--- a/mlops_on_hpc.pptx
+++ b/mlops_on_hpc.pptx
@@ -12878,8 +12878,8 @@
         </p:nvSpPr>
         <p:spPr>
           <a:xfrm>
-            <a:off x="6365318" y="5362347"/>
-            <a:ext cx="4988482" cy="461665"/>
+            <a:off x="5875460" y="5362347"/>
+            <a:ext cx="6094554" cy="461665"/>
           </a:xfrm>
           <a:prstGeom prst="rect">
             <a:avLst/>
@@ -12902,14 +12902,14 @@
                 <a:latin typeface="Courier New" panose="02070309020205020404" pitchFamily="49" charset="0"/>
                 <a:cs typeface="Courier New" panose="02070309020205020404" pitchFamily="49" charset="0"/>
               </a:rPr>
-              <a:t>dvc</a:t>
+              <a:t>Dvc</a:t>
             </a:r>
             <a:r>
               <a:rPr lang="en-US" sz="2400" dirty="0">
                 <a:latin typeface="Courier New" panose="02070309020205020404" pitchFamily="49" charset="0"/>
                 <a:cs typeface="Courier New" panose="02070309020205020404" pitchFamily="49" charset="0"/>
               </a:rPr>
-              <a:t> add</a:t>
+              <a:t> stage add</a:t>
             </a:r>
             <a:r>
               <a:rPr lang="en-US" sz="2400" dirty="0"/>
@@ -12951,7 +12951,7 @@
         <p:grpSpPr>
           <a:xfrm>
             <a:off x="2227559" y="4830010"/>
-            <a:ext cx="3988184" cy="821244"/>
+            <a:ext cx="3647901" cy="797904"/>
             <a:chOff x="2227559" y="4830010"/>
             <a:chExt cx="3988184" cy="821244"/>
           </a:xfrm>
@@ -15397,8 +15397,8 @@
         </p:nvSpPr>
         <p:spPr>
           <a:xfrm>
-            <a:off x="6365318" y="4905147"/>
-            <a:ext cx="5084084" cy="461665"/>
+            <a:off x="5690404" y="4905147"/>
+            <a:ext cx="6190156" cy="461665"/>
           </a:xfrm>
           <a:prstGeom prst="rect">
             <a:avLst/>
@@ -15428,7 +15428,7 @@
                 <a:latin typeface="Courier New" panose="02070309020205020404" pitchFamily="49" charset="0"/>
                 <a:cs typeface="Courier New" panose="02070309020205020404" pitchFamily="49" charset="0"/>
               </a:rPr>
-              <a:t> add</a:t>
+              <a:t> stage add</a:t>
             </a:r>
             <a:r>
               <a:rPr lang="en-US" sz="2400" dirty="0"/>
@@ -15469,8 +15469,8 @@
         </p:nvGrpSpPr>
         <p:grpSpPr>
           <a:xfrm>
-            <a:off x="2227559" y="4030026"/>
-            <a:ext cx="3988184" cy="1164027"/>
+            <a:off x="2227559" y="4030027"/>
+            <a:ext cx="3462845" cy="1137286"/>
             <a:chOff x="2227559" y="4487226"/>
             <a:chExt cx="3988184" cy="1164027"/>
           </a:xfrm>

</xml_diff>

<commit_message>
Fix command line option typo
</commit_message>
<xml_diff>
--- a/mlops_on_hpc.pptx
+++ b/mlops_on_hpc.pptx
@@ -30682,8 +30682,8 @@
         </p:nvSpPr>
         <p:spPr>
           <a:xfrm>
-            <a:off x="1349828" y="2292717"/>
-            <a:ext cx="7260772" cy="369332"/>
+            <a:off x="1349827" y="2292717"/>
+            <a:ext cx="7663543" cy="369332"/>
           </a:xfrm>
           <a:prstGeom prst="rect">
             <a:avLst/>
@@ -30758,7 +30758,7 @@
         <p:spPr>
           <a:xfrm>
             <a:off x="1349827" y="3361450"/>
-            <a:ext cx="7260773" cy="369332"/>
+            <a:ext cx="7663544" cy="369332"/>
           </a:xfrm>
           <a:prstGeom prst="rect">
             <a:avLst/>
@@ -30806,7 +30806,7 @@
                 <a:latin typeface="Courier New" pitchFamily="49" charset="0"/>
                 <a:cs typeface="Courier New" pitchFamily="49" charset="0"/>
               </a:rPr>
-              <a:t> exp run  --queue  -set-param 'a=3.0,4.0,5.0'</a:t>
+              <a:t> exp run  --queue  -0set-param 'a=3.0,4.0,5.0'</a:t>
             </a:r>
             <a:endParaRPr lang="nl-BE" b="1" dirty="0">
               <a:solidFill>
@@ -30832,8 +30832,8 @@
         </p:nvSpPr>
         <p:spPr>
           <a:xfrm>
-            <a:off x="1349827" y="4354374"/>
-            <a:ext cx="7260772" cy="369332"/>
+            <a:off x="1349826" y="4354374"/>
+            <a:ext cx="7663543" cy="369332"/>
           </a:xfrm>
           <a:prstGeom prst="rect">
             <a:avLst/>

</xml_diff>

<commit_message>
Fix modify stage command
</commit_message>
<xml_diff>
--- a/mlops_on_hpc.pptx
+++ b/mlops_on_hpc.pptx
@@ -441,7 +441,7 @@
           <a:p>
             <a:fld id="{8BC644CB-8FFF-4F59-B04D-9A1D2A5DB720}" type="datetimeFigureOut">
               <a:rPr lang="LID4096" smtClean="0"/>
-              <a:t>12/03/2025</a:t>
+              <a:t>02/04/2026</a:t>
             </a:fld>
             <a:endParaRPr lang="LID4096"/>
           </a:p>
@@ -858,7 +858,7 @@
           <a:p>
             <a:fld id="{29DC7A01-813B-4B59-A1CC-F2D63921E46A}" type="datetime1">
               <a:rPr lang="LID4096" smtClean="0"/>
-              <a:t>12/03/2025</a:t>
+              <a:t>02/04/2026</a:t>
             </a:fld>
             <a:endParaRPr lang="LID4096"/>
           </a:p>
@@ -1058,7 +1058,7 @@
           <a:p>
             <a:fld id="{6C2A7740-B6F2-4CC5-9AD0-B161B943DB10}" type="datetime1">
               <a:rPr lang="LID4096" smtClean="0"/>
-              <a:t>12/03/2025</a:t>
+              <a:t>02/04/2026</a:t>
             </a:fld>
             <a:endParaRPr lang="LID4096"/>
           </a:p>
@@ -1268,7 +1268,7 @@
           <a:p>
             <a:fld id="{2F94B025-8F26-4EDF-B991-413B82D6446E}" type="datetime1">
               <a:rPr lang="LID4096" smtClean="0"/>
-              <a:t>12/03/2025</a:t>
+              <a:t>02/04/2026</a:t>
             </a:fld>
             <a:endParaRPr lang="LID4096"/>
           </a:p>
@@ -1468,7 +1468,7 @@
           <a:p>
             <a:fld id="{CB5C8B8A-B2CE-4D78-88A4-476B2363B71E}" type="datetime1">
               <a:rPr lang="LID4096" smtClean="0"/>
-              <a:t>12/03/2025</a:t>
+              <a:t>02/04/2026</a:t>
             </a:fld>
             <a:endParaRPr lang="LID4096"/>
           </a:p>
@@ -1744,7 +1744,7 @@
           <a:p>
             <a:fld id="{CDDAB553-EE67-480E-BCE3-F64D7D51D294}" type="datetime1">
               <a:rPr lang="LID4096" smtClean="0"/>
-              <a:t>12/03/2025</a:t>
+              <a:t>02/04/2026</a:t>
             </a:fld>
             <a:endParaRPr lang="LID4096"/>
           </a:p>
@@ -2012,7 +2012,7 @@
           <a:p>
             <a:fld id="{CD270038-A599-4345-BE24-96A4E06BF8E3}" type="datetime1">
               <a:rPr lang="LID4096" smtClean="0"/>
-              <a:t>12/03/2025</a:t>
+              <a:t>02/04/2026</a:t>
             </a:fld>
             <a:endParaRPr lang="LID4096"/>
           </a:p>
@@ -2427,7 +2427,7 @@
           <a:p>
             <a:fld id="{44A719F7-59BE-4FD1-8AC5-F7BFCCA290D7}" type="datetime1">
               <a:rPr lang="LID4096" smtClean="0"/>
-              <a:t>12/03/2025</a:t>
+              <a:t>02/04/2026</a:t>
             </a:fld>
             <a:endParaRPr lang="LID4096"/>
           </a:p>
@@ -2569,7 +2569,7 @@
           <a:p>
             <a:fld id="{B4C93A37-6A61-4F10-A100-9676ACB86039}" type="datetime1">
               <a:rPr lang="LID4096" smtClean="0"/>
-              <a:t>12/03/2025</a:t>
+              <a:t>02/04/2026</a:t>
             </a:fld>
             <a:endParaRPr lang="LID4096"/>
           </a:p>
@@ -2682,7 +2682,7 @@
           <a:p>
             <a:fld id="{9E73F7F9-09CC-4C21-BDB8-90E2F1A013BD}" type="datetime1">
               <a:rPr lang="LID4096" smtClean="0"/>
-              <a:t>12/03/2025</a:t>
+              <a:t>02/04/2026</a:t>
             </a:fld>
             <a:endParaRPr lang="LID4096"/>
           </a:p>
@@ -2995,7 +2995,7 @@
           <a:p>
             <a:fld id="{FD166AE6-E2E5-4774-8434-34F2AD9BDDCE}" type="datetime1">
               <a:rPr lang="LID4096" smtClean="0"/>
-              <a:t>12/03/2025</a:t>
+              <a:t>02/04/2026</a:t>
             </a:fld>
             <a:endParaRPr lang="LID4096"/>
           </a:p>
@@ -3284,7 +3284,7 @@
           <a:p>
             <a:fld id="{895E2CCE-BBFE-4BEC-9002-70F26B158681}" type="datetime1">
               <a:rPr lang="LID4096" smtClean="0"/>
-              <a:t>12/03/2025</a:t>
+              <a:t>02/04/2026</a:t>
             </a:fld>
             <a:endParaRPr lang="LID4096"/>
           </a:p>
@@ -3527,7 +3527,7 @@
           <a:p>
             <a:fld id="{C795C0FD-7BB7-48C9-86F3-9771767F1BC3}" type="datetime1">
               <a:rPr lang="LID4096" smtClean="0"/>
-              <a:t>12/03/2025</a:t>
+              <a:t>02/04/2026</a:t>
             </a:fld>
             <a:endParaRPr lang="LID4096"/>
           </a:p>
@@ -19169,8 +19169,8 @@
         </p:nvSpPr>
         <p:spPr>
           <a:xfrm>
-            <a:off x="1578429" y="5646154"/>
-            <a:ext cx="8600624" cy="954107"/>
+            <a:off x="838200" y="5646154"/>
+            <a:ext cx="9889439" cy="954107"/>
           </a:xfrm>
           <a:prstGeom prst="rect">
             <a:avLst/>
@@ -19204,7 +19204,7 @@
                 <a:latin typeface="Courier New" panose="02070309020205020404" pitchFamily="49" charset="0"/>
                 <a:cs typeface="Courier New" panose="02070309020205020404" pitchFamily="49" charset="0"/>
               </a:rPr>
-              <a:t> add --force </a:t>
+              <a:t> stage add --force </a:t>
             </a:r>
             <a:r>
               <a:rPr lang="en-US" sz="2800" dirty="0">

</xml_diff>